<commit_message>
update links in pptx
</commit_message>
<xml_diff>
--- a/presentation/capstone_round2-final-IR-102026.pptx
+++ b/presentation/capstone_round2-final-IR-102026.pptx
@@ -8322,9 +8322,6 @@
           <a:bodyPr wrap="square" rtlCol="0" anchor="ctr"/>
           <a:lstStyle/>
           <a:p>
-            <a:pPr marL="0" indent="0">
-              <a:buNone/>
-            </a:pPr>
             <a:r>
               <a:rPr lang="en-US" sz="1400" b="1" dirty="0">
                 <a:solidFill>
@@ -8334,7 +8331,30 @@
                 <a:ea typeface="Calibri" pitchFamily="34" charset="-122"/>
                 <a:cs typeface="Calibri" pitchFamily="34" charset="-120"/>
               </a:rPr>
-              <a:t>🔗  [Render URL — update after deployment]</a:t>
+              <a:t>🔗  </a:t>
+            </a:r>
+            <a:r>
+              <a:rPr lang="en-US" sz="1400" dirty="0">
+                <a:solidFill>
+                  <a:srgbClr val="888888"/>
+                </a:solidFill>
+                <a:latin typeface="Calibri" pitchFamily="34" charset="0"/>
+                <a:ea typeface="Calibri" pitchFamily="34" charset="-122"/>
+                <a:cs typeface="Calibri" pitchFamily="34" charset="-120"/>
+                <a:hlinkClick r:id="rId3"/>
+              </a:rPr>
+              <a:t>https://capstone-mvp-k2pj.onrender.com</a:t>
+            </a:r>
+            <a:r>
+              <a:rPr lang="en-US" sz="1400" dirty="0">
+                <a:solidFill>
+                  <a:srgbClr val="888888"/>
+                </a:solidFill>
+                <a:latin typeface="Calibri" pitchFamily="34" charset="0"/>
+                <a:ea typeface="Calibri" pitchFamily="34" charset="-122"/>
+                <a:cs typeface="Calibri" pitchFamily="34" charset="-120"/>
+              </a:rPr>
+              <a:t> </a:t>
             </a:r>
             <a:endParaRPr lang="en-US" sz="1400" dirty="0"/>
           </a:p>

</xml_diff>